<commit_message>
Update presentation with figures from the hardware implementation
Replaces predicted/placeholder numbers with what the TRIANGULATE page
actually does (see firmware/main.c and the design doc's Implementation
section):

- ESP-NOW payload 56 B -> 114 B (16 APs, not 8)
- stage-2 solver shown as the real closed form, x = (d1^2 - d2^2 + s^2)/2s
  and theta = atan2(sqrt(d1^2 - x^2), x), with walk direction = +x
- APs are a quality metric, not a solver input: mean AP residual < 4 m
  means the geometry is consistent
- left/right is unrecoverable from ranges at all (mirroring B and every AP
  across the walk axis leaves every range unchanged), so the slides no
  longer claim stage 2 resolves it - the spin or "warmer" picks the side
- accuracy vs the closing-rate compass is flagged as not yet measured
  rather than presented as an improvement

Co-Authored-By: Claude Opus 5 <noreply@anthropic.com>
</commit_message>
<xml_diff>
--- a/presentation/badge-finder-slides.pptx
+++ b/presentation/badge-finder-slides.pptx
@@ -2772,8 +2772,8 @@
         </p:nvSpPr>
         <p:spPr>
           <a:xfrm>
-            <a:off x="7315200" y="2011680"/>
-            <a:ext cx="4233672" cy="2103120"/>
+            <a:off x="7315200" y="1920240"/>
+            <a:ext cx="4233672" cy="1737360"/>
           </a:xfrm>
           <a:prstGeom prst="rect">
             <a:avLst/>
@@ -2839,8 +2839,8 @@
         </p:nvSpPr>
         <p:spPr>
           <a:xfrm>
-            <a:off x="7315200" y="4297680"/>
-            <a:ext cx="4233672" cy="1280160"/>
+            <a:off x="7315200" y="3703320"/>
+            <a:ext cx="4233672" cy="1645920"/>
           </a:xfrm>
           <a:prstGeom prst="rect">
             <a:avLst/>
@@ -2856,6 +2856,87 @@
               <a:buNone/>
             </a:pPr>
             <a:r>
+              <a:rPr lang="en-US" sz="1500" b="1" dirty="0">
+                <a:solidFill>
+                  <a:srgbClr val="FF7A5C"/>
+                </a:solidFill>
+                <a:latin typeface="Arial" pitchFamily="34" charset="0"/>
+                <a:ea typeface="Arial" pitchFamily="34" charset="-122"/>
+                <a:cs typeface="Arial" pitchFamily="34" charset="-120"/>
+              </a:rPr>
+              <a:t>Found while implementing: </a:t>
+            </a:r>
+            <a:pPr indent="0" marL="0">
+              <a:buNone/>
+            </a:pPr>
+            <a:r>
+              <a:rPr lang="en-US" sz="1500" dirty="0">
+                <a:solidFill>
+                  <a:srgbClr val="E9E9E4"/>
+                </a:solidFill>
+                <a:latin typeface="Arial" pitchFamily="34" charset="0"/>
+                <a:ea typeface="Arial" pitchFamily="34" charset="-122"/>
+                <a:cs typeface="Arial" pitchFamily="34" charset="-120"/>
+              </a:rPr>
+              <a:t>mirror B and every AP across the walk axis and every range is unchanged. It is a </a:t>
+            </a:r>
+            <a:pPr indent="0" marL="0">
+              <a:buNone/>
+            </a:pPr>
+            <a:r>
+              <a:rPr lang="en-US" sz="1500" b="1" dirty="0">
+                <a:solidFill>
+                  <a:srgbClr val="E9E9E4"/>
+                </a:solidFill>
+                <a:latin typeface="Arial" pitchFamily="34" charset="0"/>
+                <a:ea typeface="Arial" pitchFamily="34" charset="-122"/>
+                <a:cs typeface="Arial" pitchFamily="34" charset="-120"/>
+              </a:rPr>
+              <a:t>symmetry of the data</a:t>
+            </a:r>
+            <a:pPr indent="0" marL="0">
+              <a:buNone/>
+            </a:pPr>
+            <a:r>
+              <a:rPr lang="en-US" sz="1500" dirty="0">
+                <a:solidFill>
+                  <a:srgbClr val="E9E9E4"/>
+                </a:solidFill>
+                <a:latin typeface="Arial" pitchFamily="34" charset="0"/>
+                <a:ea typeface="Arial" pitchFamily="34" charset="-122"/>
+                <a:cs typeface="Arial" pitchFamily="34" charset="-120"/>
+              </a:rPr>
+              <a:t> — more APs cannot break it.</a:t>
+            </a:r>
+            <a:endParaRPr lang="en-US" sz="1500" dirty="0"/>
+          </a:p>
+        </p:txBody>
+      </p:sp>
+      <p:sp>
+        <p:nvSpPr>
+          <p:cNvPr id="15" name="Text 13"/>
+          <p:cNvSpPr txBox="1"/>
+          <p:nvPr/>
+        </p:nvSpPr>
+        <p:spPr>
+          <a:xfrm>
+            <a:off x="7315200" y="5349240"/>
+            <a:ext cx="4233672" cy="822960"/>
+          </a:xfrm>
+          <a:prstGeom prst="rect">
+            <a:avLst/>
+          </a:prstGeom>
+          <a:noFill/>
+          <a:ln/>
+        </p:spPr>
+        <p:txBody>
+          <a:bodyPr wrap="square" lIns="0" tIns="0" rIns="0" bIns="0" rtlCol="0" anchor="ctr"/>
+          <a:lstStyle/>
+          <a:p>
+            <a:pPr indent="0" marL="0">
+              <a:buNone/>
+            </a:pPr>
+            <a:r>
               <a:rPr lang="en-US" sz="1900" b="1" dirty="0">
                 <a:solidFill>
                   <a:srgbClr val="E9E9E4"/>
@@ -2864,7 +2945,7 @@
                 <a:ea typeface="Arial" pitchFamily="34" charset="-122"/>
                 <a:cs typeface="Arial" pitchFamily="34" charset="-120"/>
               </a:rPr>
-              <a:t>Stage 1 alone cannot tell you which of the two ways to walk.</a:t>
+              <a:t>Ranges alone can never choose a side.</a:t>
             </a:r>
             <a:endParaRPr lang="en-US" sz="1900" dirty="0"/>
           </a:p>
@@ -3520,7 +3601,7 @@
                 <a:ea typeface="Arial" pitchFamily="34" charset="-122"/>
                 <a:cs typeface="Arial" pitchFamily="34" charset="-120"/>
               </a:rPr>
-              <a:t>Steps count the displacement — ≈0.72 m each</a:t>
+              <a:t>Screen prompts WALK ~5 STEPS; the accelerometer accumulates the baseline s</a:t>
             </a:r>
             <a:endParaRPr lang="en-US" sz="1450" dirty="0"/>
           </a:p>
@@ -3600,7 +3681,7 @@
                 <a:ea typeface="Arial" pitchFamily="34" charset="-122"/>
                 <a:cs typeface="Arial" pitchFamily="34" charset="-120"/>
               </a:rPr>
-              <a:t>Re-scan from A₂: only one candidate in each mirror pair fits the new distances</a:t>
+              <a:t>A₂ re-captures: ranges to B and a fresh AP scan</a:t>
             </a:r>
             <a:endParaRPr lang="en-US" sz="1450" dirty="0"/>
           </a:p>
@@ -3640,7 +3721,7 @@
                 <a:ea typeface="Arial" pitchFamily="34" charset="-122"/>
                 <a:cs typeface="Arial" pitchFamily="34" charset="-120"/>
               </a:rPr>
-              <a:t>Three anchors — A₁, B, A₂ — kill the reflection and pin the map to your walk</a:t>
+              <a:t>Solve, then score: each common AP's predicted range to the solved B is compared with what B reported</a:t>
             </a:r>
             <a:endParaRPr lang="en-US" sz="1450" dirty="0"/>
           </a:p>
@@ -3654,8 +3735,8 @@
         </p:nvSpPr>
         <p:spPr>
           <a:xfrm>
-            <a:off x="640080" y="6080760"/>
-            <a:ext cx="10881360" cy="365760"/>
+            <a:off x="640080" y="6035040"/>
+            <a:ext cx="10881360" cy="411480"/>
           </a:xfrm>
           <a:prstGeom prst="rect">
             <a:avLst/>
@@ -3679,7 +3760,7 @@
                 <a:ea typeface="Courier New" pitchFamily="34" charset="-122"/>
                 <a:cs typeface="Courier New" pitchFamily="34" charset="-120"/>
               </a:rPr>
-              <a:t>θ = arccos(−Δd / Δwalked)   keeps the compass live while you walk</a:t>
+              <a:t>x = (d₁² − d₂² + s²) / 2s        θ = atan2(√(d₁² − x²), x)        walk direction = +x</a:t>
             </a:r>
             <a:endParaRPr lang="en-US" sz="1400" dirty="0"/>
           </a:p>
@@ -3889,7 +3970,7 @@
                 <a:ea typeface="Arial" pitchFamily="34" charset="-122"/>
                 <a:cs typeface="Arial" pitchFamily="34" charset="-120"/>
               </a:rPr>
-              <a:t>expected bearing error, vs a single body-shadow spin</a:t>
+              <a:t>predicted bearing error vs a single spin — ground-truth run still pending</a:t>
             </a:r>
             <a:endParaRPr lang="en-US" sz="1350" dirty="0"/>
           </a:p>
@@ -3944,13 +4025,13 @@
             <a:r>
               <a:rPr lang="en-US" sz="3000" b="1" dirty="0">
                 <a:solidFill>
-                  <a:srgbClr val="5B96FF"/>
-                </a:solidFill>
-                <a:latin typeface="Arial" pitchFamily="34" charset="0"/>
-                <a:ea typeface="Arial" pitchFamily="34" charset="-122"/>
-                <a:cs typeface="Arial" pitchFamily="34" charset="-120"/>
-              </a:rPr>
-              <a:t>1 → 5–8</a:t>
+                  <a:srgbClr val="FF7A5C"/>
+                </a:solidFill>
+                <a:latin typeface="Arial" pitchFamily="34" charset="0"/>
+                <a:ea typeface="Arial" pitchFamily="34" charset="-122"/>
+                <a:cs typeface="Arial" pitchFamily="34" charset="-120"/>
+              </a:rPr>
+              <a:t>114 bytes</a:t>
             </a:r>
             <a:endParaRPr lang="en-US" sz="3000" dirty="0"/>
           </a:p>
@@ -3989,7 +4070,7 @@
                 <a:ea typeface="Arial" pitchFamily="34" charset="-122"/>
                 <a:cs typeface="Arial" pitchFamily="34" charset="-120"/>
               </a:rPr>
-              <a:t>constraints per capture — over-determined, robust to any one bad AP</a:t>
+              <a:t>16 APs in one ESP-NOW packet</a:t>
             </a:r>
             <a:endParaRPr lang="en-US" sz="1350" dirty="0"/>
           </a:p>
@@ -4044,13 +4125,13 @@
             <a:r>
               <a:rPr lang="en-US" sz="3000" b="1" dirty="0">
                 <a:solidFill>
-                  <a:srgbClr val="FF7A5C"/>
-                </a:solidFill>
-                <a:latin typeface="Arial" pitchFamily="34" charset="0"/>
-                <a:ea typeface="Arial" pitchFamily="34" charset="-122"/>
-                <a:cs typeface="Arial" pitchFamily="34" charset="-120"/>
-              </a:rPr>
-              <a:t>56 bytes</a:t>
+                  <a:srgbClr val="5B96FF"/>
+                </a:solidFill>
+                <a:latin typeface="Arial" pitchFamily="34" charset="0"/>
+                <a:ea typeface="Arial" pitchFamily="34" charset="-122"/>
+                <a:cs typeface="Arial" pitchFamily="34" charset="-120"/>
+              </a:rPr>
+              <a:t>&lt; 4 m</a:t>
             </a:r>
             <a:endParaRPr lang="en-US" sz="3000" dirty="0"/>
           </a:p>
@@ -4089,7 +4170,7 @@
                 <a:ea typeface="Arial" pitchFamily="34" charset="-122"/>
                 <a:cs typeface="Arial" pitchFamily="34" charset="-120"/>
               </a:rPr>
-              <a:t>of data exchanged — one ESP-NOW packet</a:t>
+              <a:t>mean AP residual on the badge ⇒ the geometry is consistent</a:t>
             </a:r>
             <a:endParaRPr lang="en-US" sz="1350" dirty="0"/>
           </a:p>
@@ -4120,6 +4201,20 @@
               <a:buNone/>
             </a:pPr>
             <a:r>
+              <a:rPr lang="en-US" sz="1550" b="1" dirty="0">
+                <a:solidFill>
+                  <a:srgbClr val="E9E9E4"/>
+                </a:solidFill>
+                <a:latin typeface="Arial" pitchFamily="34" charset="0"/>
+                <a:ea typeface="Arial" pitchFamily="34" charset="-122"/>
+                <a:cs typeface="Arial" pitchFamily="34" charset="-120"/>
+              </a:rPr>
+              <a:t>Running on both badges — the TRIANGULATE page. </a:t>
+            </a:r>
+            <a:pPr indent="0" marL="0">
+              <a:buNone/>
+            </a:pPr>
+            <a:r>
               <a:rPr lang="en-US" sz="1550" dirty="0">
                 <a:solidFill>
                   <a:srgbClr val="E9E9E4"/>
@@ -4128,21 +4223,35 @@
                 <a:ea typeface="Arial" pitchFamily="34" charset="-122"/>
                 <a:cs typeface="Arial" pitchFamily="34" charset="-120"/>
               </a:rPr>
-              <a:t>Multipath errors on different APs are largely independent — they average out. </a:t>
+              <a:t>Whether it beats the closing-rate compass already running is </a:t>
             </a:r>
             <a:pPr indent="0" marL="0">
               <a:buNone/>
             </a:pPr>
             <a:r>
+              <a:rPr lang="en-US" sz="1550" b="1" dirty="0">
+                <a:solidFill>
+                  <a:srgbClr val="FF7A5C"/>
+                </a:solidFill>
+                <a:latin typeface="Arial" pitchFamily="34" charset="0"/>
+                <a:ea typeface="Arial" pitchFamily="34" charset="-122"/>
+                <a:cs typeface="Arial" pitchFamily="34" charset="-120"/>
+              </a:rPr>
+              <a:t>not measured yet</a:t>
+            </a:r>
+            <a:pPr indent="0" marL="0">
+              <a:buNone/>
+            </a:pPr>
+            <a:r>
               <a:rPr lang="en-US" sz="1550" dirty="0">
                 <a:solidFill>
-                  <a:srgbClr val="9BA0A8"/>
-                </a:solidFill>
-                <a:latin typeface="Arial" pitchFamily="34" charset="0"/>
-                <a:ea typeface="Arial" pitchFamily="34" charset="-122"/>
-                <a:cs typeface="Arial" pitchFamily="34" charset="-120"/>
-              </a:rPr>
-              <a:t>RSSI→distance is still the weak link (factor-of-two typical): the rings are thick annuli, not thin circles.</a:t>
+                  <a:srgbClr val="E9E9E4"/>
+                </a:solidFill>
+                <a:latin typeface="Arial" pitchFamily="34" charset="0"/>
+                <a:ea typeface="Arial" pitchFamily="34" charset="-122"/>
+                <a:cs typeface="Arial" pitchFamily="34" charset="-120"/>
+              </a:rPr>
+              <a:t> — that is the next test, and the honest caveat.</a:t>
             </a:r>
             <a:endParaRPr lang="en-US" sz="1550" dirty="0"/>
           </a:p>
@@ -4643,7 +4752,28 @@
                 <a:ea typeface="Arial" pitchFamily="34" charset="-122"/>
                 <a:cs typeface="Arial" pitchFamily="34" charset="-120"/>
               </a:rPr>
-              <a:t>This is a hallway-scale finder, not an AirTag — and it says so honestly</a:t>
+              <a:t>You walk roughly straight — a curved walk breaks the baseline</a:t>
+            </a:r>
+            <a:endParaRPr lang="en-US" sz="1500" dirty="0"/>
+          </a:p>
+          <a:p>
+            <a:pPr marL="177800" indent="-177800">
+              <a:spcAft>
+                <a:spcPts val="1400"/>
+              </a:spcAft>
+              <a:buSzPct val="100000"/>
+              <a:buChar char="▪"/>
+            </a:pPr>
+            <a:r>
+              <a:rPr lang="en-US" sz="1500" dirty="0">
+                <a:solidFill>
+                  <a:srgbClr val="E9E9E4"/>
+                </a:solidFill>
+                <a:latin typeface="Arial" pitchFamily="34" charset="0"/>
+                <a:ea typeface="Arial" pitchFamily="34" charset="-122"/>
+                <a:cs typeface="Arial" pitchFamily="34" charset="-120"/>
+              </a:rPr>
+              <a:t>Hallway-scale, not an AirTag — the screen says “LEFT or RIGHT: walk one way, warmer = correct”</a:t>
             </a:r>
             <a:endParaRPr lang="en-US" sz="1500" dirty="0"/>
           </a:p>
@@ -5033,7 +5163,7 @@
                 <a:ea typeface="Arial" pitchFamily="34" charset="-122"/>
                 <a:cs typeface="Arial" pitchFamily="34" charset="-120"/>
               </a:rPr>
-              <a:t>Hack the North 2026 badge · custom ESP-IDF firmware · ±17° with three spins averaged</a:t>
+              <a:t>Hack the North 2026 badge · custom ESP-IDF firmware · TRIANGULATE page, live on two badges</a:t>
             </a:r>
             <a:endParaRPr lang="en-US" sz="1300" dirty="0"/>
           </a:p>
@@ -9416,7 +9546,7 @@
                 <a:ea typeface="Arial" pitchFamily="34" charset="-122"/>
                 <a:cs typeface="Arial" pitchFamily="34" charset="-120"/>
               </a:rPr>
-              <a:t>8 APs × (6 B BSSID + 1 B RSSI) = 56 bytes — one packet.</a:t>
+              <a:t>16 APs × (6 B BSSID + 1 B RSSI) = 114 bytes — one packet.</a:t>
             </a:r>
             <a:endParaRPr lang="en-US" sz="1700" dirty="0"/>
           </a:p>

</xml_diff>